<commit_message>
feat: Add Management Team / Founder slide to all business documents
- Added founder slide to 7 business PPTX docs (M&A Deck, Business Plan,
  Pitch Deck, Strategic Outlook, Marketing Plan, Ambassador Plan, Year 1 Financial)
- Slide highlights: 3 successful exits, 25+ years, 30+ team size,
  99.99% uptime, Stanford education, trilingual
- Also updated 4 copies in ~/Documents
- Script: add_founder_slide.py for future re-runs
</commit_message>
<xml_diff>
--- a/data/docs/business/Bandsintown_x_GigLift_MA_Deck.pptx
+++ b/data/docs/business/Bandsintown_x_GigLift_MA_Deck.pptx
@@ -20,6 +20,7 @@
     <p:sldId id="268" r:id="rId19"/>
     <p:sldId id="269" r:id="rId20"/>
     <p:sldId id="270" r:id="rId21"/>
+    <p:sldId id="271" r:id="rId22"/>
   </p:sldIdLst>
   <p:sldSz cx="12191695" cy="6858000" type="screen4x3"/>
   <p:notesSz cx="6858000" cy="9144000"/>
@@ -9152,6 +9153,1389 @@
             <a:br/>
             <a:r>
               <a:t>All projections are estimates based on publicly available information and internal analysis.</a:t>
+            </a:r>
+          </a:p>
+        </p:txBody>
+      </p:sp>
+    </p:spTree>
+  </p:cSld>
+  <p:clrMapOvr>
+    <a:masterClrMapping/>
+  </p:clrMapOvr>
+</p:sld>
+</file>
+
+<file path=ppt/slides/slide16.xml><?xml version="1.0" encoding="utf-8"?>
+<p:sld xmlns:a="http://schemas.openxmlformats.org/drawingml/2006/main" xmlns:p="http://schemas.openxmlformats.org/presentationml/2006/main" xmlns:r="http://schemas.openxmlformats.org/officeDocument/2006/relationships">
+  <p:cSld>
+    <p:bg>
+      <p:bgPr>
+        <a:solidFill>
+          <a:srgbClr val="0A0F1E"/>
+        </a:solidFill>
+        <a:effectLst/>
+      </p:bgPr>
+    </p:bg>
+    <p:spTree>
+      <p:nvGrpSpPr>
+        <p:cNvPr id="1" name=""/>
+        <p:cNvGrpSpPr/>
+        <p:nvPr/>
+      </p:nvGrpSpPr>
+      <p:grpSpPr/>
+      <p:sp>
+        <p:nvSpPr>
+          <p:cNvPr id="2" name="Rectangle 1"/>
+          <p:cNvSpPr/>
+          <p:nvPr/>
+        </p:nvSpPr>
+        <p:spPr>
+          <a:xfrm>
+            <a:off x="0" y="0"/>
+            <a:ext cx="12191695" cy="6858000"/>
+          </a:xfrm>
+          <a:prstGeom prst="rect">
+            <a:avLst/>
+          </a:prstGeom>
+          <a:gradFill rotWithShape="1">
+            <a:gsLst>
+              <a:gs pos="0">
+                <a:srgbClr val="0A0F1E"/>
+              </a:gs>
+              <a:gs pos="100000">
+                <a:srgbClr val="0C1E2D"/>
+              </a:gs>
+            </a:gsLst>
+            <a:lin scaled="0"/>
+          </a:gradFill>
+          <a:ln>
+            <a:noFill/>
+          </a:ln>
+        </p:spPr>
+        <p:style>
+          <a:lnRef idx="1">
+            <a:schemeClr val="accent1"/>
+          </a:lnRef>
+          <a:fillRef idx="3">
+            <a:schemeClr val="accent1"/>
+          </a:fillRef>
+          <a:effectRef idx="2">
+            <a:schemeClr val="accent1"/>
+          </a:effectRef>
+          <a:fontRef idx="minor">
+            <a:schemeClr val="lt1"/>
+          </a:fontRef>
+        </p:style>
+        <p:txBody>
+          <a:bodyPr rtlCol="0" anchor="ctr"/>
+          <a:lstStyle/>
+          <a:p>
+            <a:pPr algn="ctr"/>
+          </a:p>
+        </p:txBody>
+      </p:sp>
+      <p:sp>
+        <p:nvSpPr>
+          <p:cNvPr id="3" name="Rectangle 2"/>
+          <p:cNvSpPr/>
+          <p:nvPr/>
+        </p:nvSpPr>
+        <p:spPr>
+          <a:xfrm>
+            <a:off x="0" y="0"/>
+            <a:ext cx="12191695" cy="27432"/>
+          </a:xfrm>
+          <a:prstGeom prst="rect">
+            <a:avLst/>
+          </a:prstGeom>
+          <a:solidFill>
+            <a:srgbClr val="2DD4BF"/>
+          </a:solidFill>
+          <a:ln>
+            <a:noFill/>
+          </a:ln>
+        </p:spPr>
+        <p:style>
+          <a:lnRef idx="1">
+            <a:schemeClr val="accent1"/>
+          </a:lnRef>
+          <a:fillRef idx="3">
+            <a:schemeClr val="accent1"/>
+          </a:fillRef>
+          <a:effectRef idx="2">
+            <a:schemeClr val="accent1"/>
+          </a:effectRef>
+          <a:fontRef idx="minor">
+            <a:schemeClr val="lt1"/>
+          </a:fontRef>
+        </p:style>
+        <p:txBody>
+          <a:bodyPr rtlCol="0" anchor="ctr"/>
+          <a:lstStyle/>
+          <a:p>
+            <a:pPr algn="ctr"/>
+          </a:p>
+        </p:txBody>
+      </p:sp>
+      <p:sp>
+        <p:nvSpPr>
+          <p:cNvPr id="4" name="TextBox 3"/>
+          <p:cNvSpPr txBox="1"/>
+          <p:nvPr/>
+        </p:nvSpPr>
+        <p:spPr>
+          <a:xfrm>
+            <a:off x="731520" y="365760"/>
+            <a:ext cx="10058400" cy="548640"/>
+          </a:xfrm>
+          <a:prstGeom prst="rect">
+            <a:avLst/>
+          </a:prstGeom>
+          <a:noFill/>
+        </p:spPr>
+        <p:txBody>
+          <a:bodyPr wrap="square">
+            <a:spAutoFit/>
+          </a:bodyPr>
+          <a:lstStyle/>
+          <a:p>
+            <a:pPr algn="l">
+              <a:defRPr sz="3400" b="1">
+                <a:solidFill>
+                  <a:srgbClr val="FFFFFF"/>
+                </a:solidFill>
+                <a:latin typeface="Calibri"/>
+              </a:defRPr>
+            </a:pPr>
+            <a:r>
+              <a:t>Management Team</a:t>
+            </a:r>
+          </a:p>
+        </p:txBody>
+      </p:sp>
+      <p:sp>
+        <p:nvSpPr>
+          <p:cNvPr id="5" name="TextBox 4"/>
+          <p:cNvSpPr txBox="1"/>
+          <p:nvPr/>
+        </p:nvSpPr>
+        <p:spPr>
+          <a:xfrm>
+            <a:off x="731520" y="960120"/>
+            <a:ext cx="10058400" cy="274320"/>
+          </a:xfrm>
+          <a:prstGeom prst="rect">
+            <a:avLst/>
+          </a:prstGeom>
+          <a:noFill/>
+        </p:spPr>
+        <p:txBody>
+          <a:bodyPr wrap="square">
+            <a:spAutoFit/>
+          </a:bodyPr>
+          <a:lstStyle/>
+          <a:p>
+            <a:pPr algn="l">
+              <a:defRPr sz="1500" b="0">
+                <a:solidFill>
+                  <a:srgbClr val="2DD4BF"/>
+                </a:solidFill>
+                <a:latin typeface="Calibri"/>
+              </a:defRPr>
+            </a:pPr>
+            <a:r>
+              <a:t>Serial entrepreneur with a proven pattern of building, scaling, and exiting vertical SaaS</a:t>
+            </a:r>
+          </a:p>
+        </p:txBody>
+      </p:sp>
+      <p:sp>
+        <p:nvSpPr>
+          <p:cNvPr id="6" name="Rectangle 5"/>
+          <p:cNvSpPr/>
+          <p:nvPr/>
+        </p:nvSpPr>
+        <p:spPr>
+          <a:xfrm>
+            <a:off x="548640" y="1463040"/>
+            <a:ext cx="5303520" cy="4846320"/>
+          </a:xfrm>
+          <a:prstGeom prst="rect">
+            <a:avLst/>
+          </a:prstGeom>
+          <a:solidFill>
+            <a:srgbClr val="12162A"/>
+          </a:solidFill>
+          <a:ln w="12700">
+            <a:solidFill>
+              <a:srgbClr val="28324B"/>
+            </a:solidFill>
+          </a:ln>
+        </p:spPr>
+        <p:style>
+          <a:lnRef idx="1">
+            <a:schemeClr val="accent1"/>
+          </a:lnRef>
+          <a:fillRef idx="3">
+            <a:schemeClr val="accent1"/>
+          </a:fillRef>
+          <a:effectRef idx="2">
+            <a:schemeClr val="accent1"/>
+          </a:effectRef>
+          <a:fontRef idx="minor">
+            <a:schemeClr val="lt1"/>
+          </a:fontRef>
+        </p:style>
+        <p:txBody>
+          <a:bodyPr rtlCol="0" anchor="ctr"/>
+          <a:lstStyle/>
+          <a:p>
+            <a:pPr algn="ctr"/>
+          </a:p>
+        </p:txBody>
+      </p:sp>
+      <p:sp>
+        <p:nvSpPr>
+          <p:cNvPr id="7" name="TextBox 6"/>
+          <p:cNvSpPr txBox="1"/>
+          <p:nvPr/>
+        </p:nvSpPr>
+        <p:spPr>
+          <a:xfrm>
+            <a:off x="731520" y="1600200"/>
+            <a:ext cx="4937760" cy="365760"/>
+          </a:xfrm>
+          <a:prstGeom prst="rect">
+            <a:avLst/>
+          </a:prstGeom>
+          <a:noFill/>
+        </p:spPr>
+        <p:txBody>
+          <a:bodyPr wrap="square">
+            <a:spAutoFit/>
+          </a:bodyPr>
+          <a:lstStyle/>
+          <a:p>
+            <a:pPr algn="l">
+              <a:defRPr sz="1500" b="1">
+                <a:solidFill>
+                  <a:srgbClr val="A855F7"/>
+                </a:solidFill>
+                <a:latin typeface="Calibri"/>
+              </a:defRPr>
+            </a:pPr>
+            <a:r>
+              <a:t>BLAKE THORNLEY  —  FOUNDER &amp; CTO</a:t>
+            </a:r>
+          </a:p>
+        </p:txBody>
+      </p:sp>
+      <p:sp>
+        <p:nvSpPr>
+          <p:cNvPr id="8" name="TextBox 7"/>
+          <p:cNvSpPr txBox="1"/>
+          <p:nvPr/>
+        </p:nvSpPr>
+        <p:spPr>
+          <a:xfrm>
+            <a:off x="822960" y="1965960"/>
+            <a:ext cx="4846320" cy="274320"/>
+          </a:xfrm>
+          <a:prstGeom prst="rect">
+            <a:avLst/>
+          </a:prstGeom>
+          <a:noFill/>
+        </p:spPr>
+        <p:txBody>
+          <a:bodyPr wrap="square">
+            <a:spAutoFit/>
+          </a:bodyPr>
+          <a:lstStyle/>
+          <a:p>
+            <a:pPr algn="l">
+              <a:defRPr sz="1200" b="0">
+                <a:solidFill>
+                  <a:srgbClr val="C8C8DC"/>
+                </a:solidFill>
+                <a:latin typeface="Calibri"/>
+              </a:defRPr>
+            </a:pPr>
+            <a:r>
+              <a:t>• 25+ years building and scaling cloud-native SaaS platforms</a:t>
+            </a:r>
+          </a:p>
+        </p:txBody>
+      </p:sp>
+      <p:sp>
+        <p:nvSpPr>
+          <p:cNvPr id="9" name="TextBox 8"/>
+          <p:cNvSpPr txBox="1"/>
+          <p:nvPr/>
+        </p:nvSpPr>
+        <p:spPr>
+          <a:xfrm>
+            <a:off x="822960" y="2212848"/>
+            <a:ext cx="4846320" cy="274320"/>
+          </a:xfrm>
+          <a:prstGeom prst="rect">
+            <a:avLst/>
+          </a:prstGeom>
+          <a:noFill/>
+        </p:spPr>
+        <p:txBody>
+          <a:bodyPr wrap="square">
+            <a:spAutoFit/>
+          </a:bodyPr>
+          <a:lstStyle/>
+          <a:p>
+            <a:pPr algn="l">
+              <a:defRPr sz="1200" b="0">
+                <a:solidFill>
+                  <a:srgbClr val="C8C8DC"/>
+                </a:solidFill>
+                <a:latin typeface="Calibri"/>
+              </a:defRPr>
+            </a:pPr>
+            <a:r>
+              <a:t>• Three-time co-founder with 3 successful exits via acquisition</a:t>
+            </a:r>
+          </a:p>
+        </p:txBody>
+      </p:sp>
+      <p:sp>
+        <p:nvSpPr>
+          <p:cNvPr id="10" name="TextBox 9"/>
+          <p:cNvSpPr txBox="1"/>
+          <p:nvPr/>
+        </p:nvSpPr>
+        <p:spPr>
+          <a:xfrm>
+            <a:off x="822960" y="2459736"/>
+            <a:ext cx="4846320" cy="274320"/>
+          </a:xfrm>
+          <a:prstGeom prst="rect">
+            <a:avLst/>
+          </a:prstGeom>
+          <a:noFill/>
+        </p:spPr>
+        <p:txBody>
+          <a:bodyPr wrap="square">
+            <a:spAutoFit/>
+          </a:bodyPr>
+          <a:lstStyle/>
+          <a:p>
+            <a:pPr algn="l">
+              <a:defRPr sz="1200" b="0">
+                <a:solidFill>
+                  <a:srgbClr val="C8C8DC"/>
+                </a:solidFill>
+                <a:latin typeface="Calibri"/>
+              </a:defRPr>
+            </a:pPr>
+            <a:r>
+              <a:t>• Led globally distributed engineering teams of 30+</a:t>
+            </a:r>
+          </a:p>
+        </p:txBody>
+      </p:sp>
+      <p:sp>
+        <p:nvSpPr>
+          <p:cNvPr id="11" name="TextBox 10"/>
+          <p:cNvSpPr txBox="1"/>
+          <p:nvPr/>
+        </p:nvSpPr>
+        <p:spPr>
+          <a:xfrm>
+            <a:off x="822960" y="2706624"/>
+            <a:ext cx="4846320" cy="274320"/>
+          </a:xfrm>
+          <a:prstGeom prst="rect">
+            <a:avLst/>
+          </a:prstGeom>
+          <a:noFill/>
+        </p:spPr>
+        <p:txBody>
+          <a:bodyPr wrap="square">
+            <a:spAutoFit/>
+          </a:bodyPr>
+          <a:lstStyle/>
+          <a:p>
+            <a:pPr algn="l">
+              <a:defRPr sz="1200" b="0">
+                <a:solidFill>
+                  <a:srgbClr val="C8C8DC"/>
+                </a:solidFill>
+                <a:latin typeface="Calibri"/>
+              </a:defRPr>
+            </a:pPr>
+            <a:r>
+              <a:t>• 99.99% uptime, reduced infrastructure costs by 50%</a:t>
+            </a:r>
+          </a:p>
+        </p:txBody>
+      </p:sp>
+      <p:sp>
+        <p:nvSpPr>
+          <p:cNvPr id="12" name="TextBox 11"/>
+          <p:cNvSpPr txBox="1"/>
+          <p:nvPr/>
+        </p:nvSpPr>
+        <p:spPr>
+          <a:xfrm>
+            <a:off x="822960" y="2953512"/>
+            <a:ext cx="4846320" cy="274320"/>
+          </a:xfrm>
+          <a:prstGeom prst="rect">
+            <a:avLst/>
+          </a:prstGeom>
+          <a:noFill/>
+        </p:spPr>
+        <p:txBody>
+          <a:bodyPr wrap="square">
+            <a:spAutoFit/>
+          </a:bodyPr>
+          <a:lstStyle/>
+          <a:p>
+            <a:pPr algn="l">
+              <a:defRPr sz="1200" b="0">
+                <a:solidFill>
+                  <a:srgbClr val="C8C8DC"/>
+                </a:solidFill>
+                <a:latin typeface="Calibri"/>
+              </a:defRPr>
+            </a:pPr>
+            <a:r>
+              <a:t>• Deep expertise in cybersecurity &amp; SOC 2 compliance</a:t>
+            </a:r>
+          </a:p>
+        </p:txBody>
+      </p:sp>
+      <p:sp>
+        <p:nvSpPr>
+          <p:cNvPr id="13" name="TextBox 12"/>
+          <p:cNvSpPr txBox="1"/>
+          <p:nvPr/>
+        </p:nvSpPr>
+        <p:spPr>
+          <a:xfrm>
+            <a:off x="822960" y="3200400"/>
+            <a:ext cx="4846320" cy="274320"/>
+          </a:xfrm>
+          <a:prstGeom prst="rect">
+            <a:avLst/>
+          </a:prstGeom>
+          <a:noFill/>
+        </p:spPr>
+        <p:txBody>
+          <a:bodyPr wrap="square">
+            <a:spAutoFit/>
+          </a:bodyPr>
+          <a:lstStyle/>
+          <a:p>
+            <a:pPr algn="l">
+              <a:defRPr sz="1200" b="0">
+                <a:solidFill>
+                  <a:srgbClr val="C8C8DC"/>
+                </a:solidFill>
+                <a:latin typeface="Calibri"/>
+              </a:defRPr>
+            </a:pPr>
+          </a:p>
+        </p:txBody>
+      </p:sp>
+      <p:sp>
+        <p:nvSpPr>
+          <p:cNvPr id="14" name="TextBox 13"/>
+          <p:cNvSpPr txBox="1"/>
+          <p:nvPr/>
+        </p:nvSpPr>
+        <p:spPr>
+          <a:xfrm>
+            <a:off x="822960" y="3447288"/>
+            <a:ext cx="4846320" cy="274320"/>
+          </a:xfrm>
+          <a:prstGeom prst="rect">
+            <a:avLst/>
+          </a:prstGeom>
+          <a:noFill/>
+        </p:spPr>
+        <p:txBody>
+          <a:bodyPr wrap="square">
+            <a:spAutoFit/>
+          </a:bodyPr>
+          <a:lstStyle/>
+          <a:p>
+            <a:pPr algn="l">
+              <a:defRPr sz="1200" b="0">
+                <a:solidFill>
+                  <a:srgbClr val="C8C8DC"/>
+                </a:solidFill>
+                <a:latin typeface="Calibri"/>
+              </a:defRPr>
+            </a:pPr>
+            <a:r>
+              <a:t>• Education:</a:t>
+            </a:r>
+          </a:p>
+        </p:txBody>
+      </p:sp>
+      <p:sp>
+        <p:nvSpPr>
+          <p:cNvPr id="15" name="TextBox 14"/>
+          <p:cNvSpPr txBox="1"/>
+          <p:nvPr/>
+        </p:nvSpPr>
+        <p:spPr>
+          <a:xfrm>
+            <a:off x="822960" y="3694176"/>
+            <a:ext cx="4846320" cy="274320"/>
+          </a:xfrm>
+          <a:prstGeom prst="rect">
+            <a:avLst/>
+          </a:prstGeom>
+          <a:noFill/>
+        </p:spPr>
+        <p:txBody>
+          <a:bodyPr wrap="square">
+            <a:spAutoFit/>
+          </a:bodyPr>
+          <a:lstStyle/>
+          <a:p>
+            <a:pPr algn="l">
+              <a:defRPr sz="1200" b="0">
+                <a:solidFill>
+                  <a:srgbClr val="C8C8DC"/>
+                </a:solidFill>
+                <a:latin typeface="Calibri"/>
+              </a:defRPr>
+            </a:pPr>
+            <a:r>
+              <a:t>  Stanford University — Software Security, Cryptography, Startup Engineering</a:t>
+            </a:r>
+          </a:p>
+        </p:txBody>
+      </p:sp>
+      <p:sp>
+        <p:nvSpPr>
+          <p:cNvPr id="16" name="TextBox 15"/>
+          <p:cNvSpPr txBox="1"/>
+          <p:nvPr/>
+        </p:nvSpPr>
+        <p:spPr>
+          <a:xfrm>
+            <a:off x="822960" y="3941064"/>
+            <a:ext cx="4846320" cy="274320"/>
+          </a:xfrm>
+          <a:prstGeom prst="rect">
+            <a:avLst/>
+          </a:prstGeom>
+          <a:noFill/>
+        </p:spPr>
+        <p:txBody>
+          <a:bodyPr wrap="square">
+            <a:spAutoFit/>
+          </a:bodyPr>
+          <a:lstStyle/>
+          <a:p>
+            <a:pPr algn="l">
+              <a:defRPr sz="1200" b="0">
+                <a:solidFill>
+                  <a:srgbClr val="C8C8DC"/>
+                </a:solidFill>
+                <a:latin typeface="Calibri"/>
+              </a:defRPr>
+            </a:pPr>
+            <a:r>
+              <a:t>  University of Redlands — Management Information Systems</a:t>
+            </a:r>
+          </a:p>
+        </p:txBody>
+      </p:sp>
+      <p:sp>
+        <p:nvSpPr>
+          <p:cNvPr id="17" name="TextBox 16"/>
+          <p:cNvSpPr txBox="1"/>
+          <p:nvPr/>
+        </p:nvSpPr>
+        <p:spPr>
+          <a:xfrm>
+            <a:off x="822960" y="4187952"/>
+            <a:ext cx="4846320" cy="274320"/>
+          </a:xfrm>
+          <a:prstGeom prst="rect">
+            <a:avLst/>
+          </a:prstGeom>
+          <a:noFill/>
+        </p:spPr>
+        <p:txBody>
+          <a:bodyPr wrap="square">
+            <a:spAutoFit/>
+          </a:bodyPr>
+          <a:lstStyle/>
+          <a:p>
+            <a:pPr algn="l">
+              <a:defRPr sz="1200" b="0">
+                <a:solidFill>
+                  <a:srgbClr val="C8C8DC"/>
+                </a:solidFill>
+                <a:latin typeface="Calibri"/>
+              </a:defRPr>
+            </a:pPr>
+          </a:p>
+        </p:txBody>
+      </p:sp>
+      <p:sp>
+        <p:nvSpPr>
+          <p:cNvPr id="18" name="TextBox 17"/>
+          <p:cNvSpPr txBox="1"/>
+          <p:nvPr/>
+        </p:nvSpPr>
+        <p:spPr>
+          <a:xfrm>
+            <a:off x="822960" y="4434840"/>
+            <a:ext cx="4846320" cy="274320"/>
+          </a:xfrm>
+          <a:prstGeom prst="rect">
+            <a:avLst/>
+          </a:prstGeom>
+          <a:noFill/>
+        </p:spPr>
+        <p:txBody>
+          <a:bodyPr wrap="square">
+            <a:spAutoFit/>
+          </a:bodyPr>
+          <a:lstStyle/>
+          <a:p>
+            <a:pPr algn="l">
+              <a:defRPr sz="1200" b="0">
+                <a:solidFill>
+                  <a:srgbClr val="C8C8DC"/>
+                </a:solidFill>
+                <a:latin typeface="Calibri"/>
+              </a:defRPr>
+            </a:pPr>
+            <a:r>
+              <a:t>• Languages: English (native), Spanish (fluent), French (intermediate)</a:t>
+            </a:r>
+          </a:p>
+        </p:txBody>
+      </p:sp>
+      <p:sp>
+        <p:nvSpPr>
+          <p:cNvPr id="19" name="Rectangle 18"/>
+          <p:cNvSpPr/>
+          <p:nvPr/>
+        </p:nvSpPr>
+        <p:spPr>
+          <a:xfrm>
+            <a:off x="6217920" y="1463040"/>
+            <a:ext cx="5303520" cy="4846320"/>
+          </a:xfrm>
+          <a:prstGeom prst="rect">
+            <a:avLst/>
+          </a:prstGeom>
+          <a:solidFill>
+            <a:srgbClr val="12162A"/>
+          </a:solidFill>
+          <a:ln w="12700">
+            <a:solidFill>
+              <a:srgbClr val="28324B"/>
+            </a:solidFill>
+          </a:ln>
+        </p:spPr>
+        <p:style>
+          <a:lnRef idx="1">
+            <a:schemeClr val="accent1"/>
+          </a:lnRef>
+          <a:fillRef idx="3">
+            <a:schemeClr val="accent1"/>
+          </a:fillRef>
+          <a:effectRef idx="2">
+            <a:schemeClr val="accent1"/>
+          </a:effectRef>
+          <a:fontRef idx="minor">
+            <a:schemeClr val="lt1"/>
+          </a:fontRef>
+        </p:style>
+        <p:txBody>
+          <a:bodyPr rtlCol="0" anchor="ctr"/>
+          <a:lstStyle/>
+          <a:p>
+            <a:pPr algn="ctr"/>
+          </a:p>
+        </p:txBody>
+      </p:sp>
+      <p:sp>
+        <p:nvSpPr>
+          <p:cNvPr id="20" name="TextBox 19"/>
+          <p:cNvSpPr txBox="1"/>
+          <p:nvPr/>
+        </p:nvSpPr>
+        <p:spPr>
+          <a:xfrm>
+            <a:off x="6400800" y="1600200"/>
+            <a:ext cx="4937760" cy="365760"/>
+          </a:xfrm>
+          <a:prstGeom prst="rect">
+            <a:avLst/>
+          </a:prstGeom>
+          <a:noFill/>
+        </p:spPr>
+        <p:txBody>
+          <a:bodyPr wrap="square">
+            <a:spAutoFit/>
+          </a:bodyPr>
+          <a:lstStyle/>
+          <a:p>
+            <a:pPr algn="l">
+              <a:defRPr sz="1500" b="1">
+                <a:solidFill>
+                  <a:srgbClr val="4ADE80"/>
+                </a:solidFill>
+                <a:latin typeface="Calibri"/>
+              </a:defRPr>
+            </a:pPr>
+            <a:r>
+              <a:t>TRACK RECORD: 3 EXITS</a:t>
+            </a:r>
+          </a:p>
+        </p:txBody>
+      </p:sp>
+      <p:sp>
+        <p:nvSpPr>
+          <p:cNvPr id="21" name="TextBox 20"/>
+          <p:cNvSpPr txBox="1"/>
+          <p:nvPr/>
+        </p:nvSpPr>
+        <p:spPr>
+          <a:xfrm>
+            <a:off x="6492240" y="1965960"/>
+            <a:ext cx="4846320" cy="274320"/>
+          </a:xfrm>
+          <a:prstGeom prst="rect">
+            <a:avLst/>
+          </a:prstGeom>
+          <a:noFill/>
+        </p:spPr>
+        <p:txBody>
+          <a:bodyPr wrap="square">
+            <a:spAutoFit/>
+          </a:bodyPr>
+          <a:lstStyle/>
+          <a:p>
+            <a:pPr algn="l">
+              <a:defRPr sz="1200" b="0">
+                <a:solidFill>
+                  <a:srgbClr val="C8C8DC"/>
+                </a:solidFill>
+                <a:latin typeface="Calibri"/>
+              </a:defRPr>
+            </a:pPr>
+            <a:r>
+              <a:t>• ✅  D4 Sports, Inc.  (Co-Founder / VP Technology)</a:t>
+            </a:r>
+          </a:p>
+        </p:txBody>
+      </p:sp>
+      <p:sp>
+        <p:nvSpPr>
+          <p:cNvPr id="22" name="TextBox 21"/>
+          <p:cNvSpPr txBox="1"/>
+          <p:nvPr/>
+        </p:nvSpPr>
+        <p:spPr>
+          <a:xfrm>
+            <a:off x="6492240" y="2212848"/>
+            <a:ext cx="4846320" cy="274320"/>
+          </a:xfrm>
+          <a:prstGeom prst="rect">
+            <a:avLst/>
+          </a:prstGeom>
+          <a:noFill/>
+        </p:spPr>
+        <p:txBody>
+          <a:bodyPr wrap="square">
+            <a:spAutoFit/>
+          </a:bodyPr>
+          <a:lstStyle/>
+          <a:p>
+            <a:pPr algn="l">
+              <a:defRPr sz="1200" b="0">
+                <a:solidFill>
+                  <a:srgbClr val="C8C8DC"/>
+                </a:solidFill>
+                <a:latin typeface="Calibri"/>
+              </a:defRPr>
+            </a:pPr>
+            <a:r>
+              <a:t>      League management SaaS → founding team to 25 employees</a:t>
+            </a:r>
+          </a:p>
+        </p:txBody>
+      </p:sp>
+      <p:sp>
+        <p:nvSpPr>
+          <p:cNvPr id="23" name="TextBox 22"/>
+          <p:cNvSpPr txBox="1"/>
+          <p:nvPr/>
+        </p:nvSpPr>
+        <p:spPr>
+          <a:xfrm>
+            <a:off x="6492240" y="2459736"/>
+            <a:ext cx="4846320" cy="274320"/>
+          </a:xfrm>
+          <a:prstGeom prst="rect">
+            <a:avLst/>
+          </a:prstGeom>
+          <a:noFill/>
+        </p:spPr>
+        <p:txBody>
+          <a:bodyPr wrap="square">
+            <a:spAutoFit/>
+          </a:bodyPr>
+          <a:lstStyle/>
+          <a:p>
+            <a:pPr algn="l">
+              <a:defRPr sz="1200" b="0">
+                <a:solidFill>
+                  <a:srgbClr val="C8C8DC"/>
+                </a:solidFill>
+                <a:latin typeface="Calibri"/>
+              </a:defRPr>
+            </a:pPr>
+            <a:r>
+              <a:t>      $500K+ ARR → Acquired by Clubspaces</a:t>
+            </a:r>
+          </a:p>
+        </p:txBody>
+      </p:sp>
+      <p:sp>
+        <p:nvSpPr>
+          <p:cNvPr id="24" name="TextBox 23"/>
+          <p:cNvSpPr txBox="1"/>
+          <p:nvPr/>
+        </p:nvSpPr>
+        <p:spPr>
+          <a:xfrm>
+            <a:off x="6492240" y="2706624"/>
+            <a:ext cx="4846320" cy="274320"/>
+          </a:xfrm>
+          <a:prstGeom prst="rect">
+            <a:avLst/>
+          </a:prstGeom>
+          <a:noFill/>
+        </p:spPr>
+        <p:txBody>
+          <a:bodyPr wrap="square">
+            <a:spAutoFit/>
+          </a:bodyPr>
+          <a:lstStyle/>
+          <a:p>
+            <a:pPr algn="l">
+              <a:defRPr sz="1200" b="0">
+                <a:solidFill>
+                  <a:srgbClr val="C8C8DC"/>
+                </a:solidFill>
+                <a:latin typeface="Calibri"/>
+              </a:defRPr>
+            </a:pPr>
+          </a:p>
+        </p:txBody>
+      </p:sp>
+      <p:sp>
+        <p:nvSpPr>
+          <p:cNvPr id="25" name="TextBox 24"/>
+          <p:cNvSpPr txBox="1"/>
+          <p:nvPr/>
+        </p:nvSpPr>
+        <p:spPr>
+          <a:xfrm>
+            <a:off x="6492240" y="2953512"/>
+            <a:ext cx="4846320" cy="274320"/>
+          </a:xfrm>
+          <a:prstGeom prst="rect">
+            <a:avLst/>
+          </a:prstGeom>
+          <a:noFill/>
+        </p:spPr>
+        <p:txBody>
+          <a:bodyPr wrap="square">
+            <a:spAutoFit/>
+          </a:bodyPr>
+          <a:lstStyle/>
+          <a:p>
+            <a:pPr algn="l">
+              <a:defRPr sz="1200" b="0">
+                <a:solidFill>
+                  <a:srgbClr val="C8C8DC"/>
+                </a:solidFill>
+                <a:latin typeface="Calibri"/>
+              </a:defRPr>
+            </a:pPr>
+            <a:r>
+              <a:t>• ✅  Clubspaces, Inc.  (VP, IT &amp; Architecture)</a:t>
+            </a:r>
+          </a:p>
+        </p:txBody>
+      </p:sp>
+      <p:sp>
+        <p:nvSpPr>
+          <p:cNvPr id="26" name="TextBox 25"/>
+          <p:cNvSpPr txBox="1"/>
+          <p:nvPr/>
+        </p:nvSpPr>
+        <p:spPr>
+          <a:xfrm>
+            <a:off x="6492240" y="3200400"/>
+            <a:ext cx="4846320" cy="274320"/>
+          </a:xfrm>
+          <a:prstGeom prst="rect">
+            <a:avLst/>
+          </a:prstGeom>
+          <a:noFill/>
+        </p:spPr>
+        <p:txBody>
+          <a:bodyPr wrap="square">
+            <a:spAutoFit/>
+          </a:bodyPr>
+          <a:lstStyle/>
+          <a:p>
+            <a:pPr algn="l">
+              <a:defRPr sz="1200" b="0">
+                <a:solidFill>
+                  <a:srgbClr val="C8C8DC"/>
+                </a:solidFill>
+                <a:latin typeface="Calibri"/>
+              </a:defRPr>
+            </a:pPr>
+            <a:r>
+              <a:t>      30-person engineering dept, $1M+ revenue, 1M+ users</a:t>
+            </a:r>
+          </a:p>
+        </p:txBody>
+      </p:sp>
+      <p:sp>
+        <p:nvSpPr>
+          <p:cNvPr id="27" name="TextBox 26"/>
+          <p:cNvSpPr txBox="1"/>
+          <p:nvPr/>
+        </p:nvSpPr>
+        <p:spPr>
+          <a:xfrm>
+            <a:off x="6492240" y="3447288"/>
+            <a:ext cx="4846320" cy="274320"/>
+          </a:xfrm>
+          <a:prstGeom prst="rect">
+            <a:avLst/>
+          </a:prstGeom>
+          <a:noFill/>
+        </p:spPr>
+        <p:txBody>
+          <a:bodyPr wrap="square">
+            <a:spAutoFit/>
+          </a:bodyPr>
+          <a:lstStyle/>
+          <a:p>
+            <a:pPr algn="l">
+              <a:defRPr sz="1200" b="0">
+                <a:solidFill>
+                  <a:srgbClr val="C8C8DC"/>
+                </a:solidFill>
+                <a:latin typeface="Calibri"/>
+              </a:defRPr>
+            </a:pPr>
+            <a:r>
+              <a:t>      LA Galaxy &amp; DC United contracts → Acquired by Active Network</a:t>
+            </a:r>
+          </a:p>
+        </p:txBody>
+      </p:sp>
+      <p:sp>
+        <p:nvSpPr>
+          <p:cNvPr id="28" name="TextBox 27"/>
+          <p:cNvSpPr txBox="1"/>
+          <p:nvPr/>
+        </p:nvSpPr>
+        <p:spPr>
+          <a:xfrm>
+            <a:off x="6492240" y="3694176"/>
+            <a:ext cx="4846320" cy="274320"/>
+          </a:xfrm>
+          <a:prstGeom prst="rect">
+            <a:avLst/>
+          </a:prstGeom>
+          <a:noFill/>
+        </p:spPr>
+        <p:txBody>
+          <a:bodyPr wrap="square">
+            <a:spAutoFit/>
+          </a:bodyPr>
+          <a:lstStyle/>
+          <a:p>
+            <a:pPr algn="l">
+              <a:defRPr sz="1200" b="0">
+                <a:solidFill>
+                  <a:srgbClr val="C8C8DC"/>
+                </a:solidFill>
+                <a:latin typeface="Calibri"/>
+              </a:defRPr>
+            </a:pPr>
+          </a:p>
+        </p:txBody>
+      </p:sp>
+      <p:sp>
+        <p:nvSpPr>
+          <p:cNvPr id="29" name="TextBox 28"/>
+          <p:cNvSpPr txBox="1"/>
+          <p:nvPr/>
+        </p:nvSpPr>
+        <p:spPr>
+          <a:xfrm>
+            <a:off x="6492240" y="3941064"/>
+            <a:ext cx="4846320" cy="274320"/>
+          </a:xfrm>
+          <a:prstGeom prst="rect">
+            <a:avLst/>
+          </a:prstGeom>
+          <a:noFill/>
+        </p:spPr>
+        <p:txBody>
+          <a:bodyPr wrap="square">
+            <a:spAutoFit/>
+          </a:bodyPr>
+          <a:lstStyle/>
+          <a:p>
+            <a:pPr algn="l">
+              <a:defRPr sz="1200" b="0">
+                <a:solidFill>
+                  <a:srgbClr val="C8C8DC"/>
+                </a:solidFill>
+                <a:latin typeface="Calibri"/>
+              </a:defRPr>
+            </a:pPr>
+            <a:r>
+              <a:t>• ✅  Total Global Sports  (Co-Founder / CTO / Board)</a:t>
+            </a:r>
+          </a:p>
+        </p:txBody>
+      </p:sp>
+      <p:sp>
+        <p:nvSpPr>
+          <p:cNvPr id="30" name="TextBox 29"/>
+          <p:cNvSpPr txBox="1"/>
+          <p:nvPr/>
+        </p:nvSpPr>
+        <p:spPr>
+          <a:xfrm>
+            <a:off x="6492240" y="4187952"/>
+            <a:ext cx="4846320" cy="274320"/>
+          </a:xfrm>
+          <a:prstGeom prst="rect">
+            <a:avLst/>
+          </a:prstGeom>
+          <a:noFill/>
+        </p:spPr>
+        <p:txBody>
+          <a:bodyPr wrap="square">
+            <a:spAutoFit/>
+          </a:bodyPr>
+          <a:lstStyle/>
+          <a:p>
+            <a:pPr algn="l">
+              <a:defRPr sz="1200" b="0">
+                <a:solidFill>
+                  <a:srgbClr val="C8C8DC"/>
+                </a:solidFill>
+                <a:latin typeface="Calibri"/>
+              </a:defRPr>
+            </a:pPr>
+            <a:r>
+              <a:t>      99.99% uptime, 12 engineers, 50% AWS cost reduction</a:t>
+            </a:r>
+          </a:p>
+        </p:txBody>
+      </p:sp>
+      <p:sp>
+        <p:nvSpPr>
+          <p:cNvPr id="31" name="TextBox 30"/>
+          <p:cNvSpPr txBox="1"/>
+          <p:nvPr/>
+        </p:nvSpPr>
+        <p:spPr>
+          <a:xfrm>
+            <a:off x="6492240" y="4434840"/>
+            <a:ext cx="4846320" cy="274320"/>
+          </a:xfrm>
+          <a:prstGeom prst="rect">
+            <a:avLst/>
+          </a:prstGeom>
+          <a:noFill/>
+        </p:spPr>
+        <p:txBody>
+          <a:bodyPr wrap="square">
+            <a:spAutoFit/>
+          </a:bodyPr>
+          <a:lstStyle/>
+          <a:p>
+            <a:pPr algn="l">
+              <a:defRPr sz="1200" b="0">
+                <a:solidFill>
+                  <a:srgbClr val="C8C8DC"/>
+                </a:solidFill>
+                <a:latin typeface="Calibri"/>
+              </a:defRPr>
+            </a:pPr>
+            <a:r>
+              <a:t>      8-year run → Acquired by AthleteOne</a:t>
+            </a:r>
+          </a:p>
+        </p:txBody>
+      </p:sp>
+      <p:sp>
+        <p:nvSpPr>
+          <p:cNvPr id="32" name="TextBox 31"/>
+          <p:cNvSpPr txBox="1"/>
+          <p:nvPr/>
+        </p:nvSpPr>
+        <p:spPr>
+          <a:xfrm>
+            <a:off x="6492240" y="4681728"/>
+            <a:ext cx="4846320" cy="274320"/>
+          </a:xfrm>
+          <a:prstGeom prst="rect">
+            <a:avLst/>
+          </a:prstGeom>
+          <a:noFill/>
+        </p:spPr>
+        <p:txBody>
+          <a:bodyPr wrap="square">
+            <a:spAutoFit/>
+          </a:bodyPr>
+          <a:lstStyle/>
+          <a:p>
+            <a:pPr algn="l">
+              <a:defRPr sz="1200" b="0">
+                <a:solidFill>
+                  <a:srgbClr val="C8C8DC"/>
+                </a:solidFill>
+                <a:latin typeface="Calibri"/>
+              </a:defRPr>
+            </a:pPr>
+          </a:p>
+        </p:txBody>
+      </p:sp>
+      <p:sp>
+        <p:nvSpPr>
+          <p:cNvPr id="33" name="TextBox 32"/>
+          <p:cNvSpPr txBox="1"/>
+          <p:nvPr/>
+        </p:nvSpPr>
+        <p:spPr>
+          <a:xfrm>
+            <a:off x="6492240" y="4928616"/>
+            <a:ext cx="4846320" cy="274320"/>
+          </a:xfrm>
+          <a:prstGeom prst="rect">
+            <a:avLst/>
+          </a:prstGeom>
+          <a:noFill/>
+        </p:spPr>
+        <p:txBody>
+          <a:bodyPr wrap="square">
+            <a:spAutoFit/>
+          </a:bodyPr>
+          <a:lstStyle/>
+          <a:p>
+            <a:pPr algn="l">
+              <a:defRPr sz="1200" b="0">
+                <a:solidFill>
+                  <a:srgbClr val="C8C8DC"/>
+                </a:solidFill>
+                <a:latin typeface="Calibri"/>
+              </a:defRPr>
+            </a:pPr>
+            <a:r>
+              <a:t>• Now applying the same playbook to music tech with GigLift</a:t>
+            </a:r>
+          </a:p>
+        </p:txBody>
+      </p:sp>
+      <p:sp>
+        <p:nvSpPr>
+          <p:cNvPr id="34" name="TextBox 33"/>
+          <p:cNvSpPr txBox="1"/>
+          <p:nvPr/>
+        </p:nvSpPr>
+        <p:spPr>
+          <a:xfrm>
+            <a:off x="548640" y="6446520"/>
+            <a:ext cx="2011680" cy="320040"/>
+          </a:xfrm>
+          <a:prstGeom prst="rect">
+            <a:avLst/>
+          </a:prstGeom>
+          <a:noFill/>
+        </p:spPr>
+        <p:txBody>
+          <a:bodyPr wrap="square">
+            <a:spAutoFit/>
+          </a:bodyPr>
+          <a:lstStyle/>
+          <a:p>
+            <a:pPr algn="ctr">
+              <a:defRPr sz="2200" b="1">
+                <a:solidFill>
+                  <a:srgbClr val="2DD4BF"/>
+                </a:solidFill>
+                <a:latin typeface="Calibri"/>
+              </a:defRPr>
+            </a:pPr>
+            <a:r>
+              <a:t>3</a:t>
+            </a:r>
+          </a:p>
+        </p:txBody>
+      </p:sp>
+      <p:sp>
+        <p:nvSpPr>
+          <p:cNvPr id="35" name="TextBox 34"/>
+          <p:cNvSpPr txBox="1"/>
+          <p:nvPr/>
+        </p:nvSpPr>
+        <p:spPr>
+          <a:xfrm>
+            <a:off x="2834640" y="6446520"/>
+            <a:ext cx="2011680" cy="320040"/>
+          </a:xfrm>
+          <a:prstGeom prst="rect">
+            <a:avLst/>
+          </a:prstGeom>
+          <a:noFill/>
+        </p:spPr>
+        <p:txBody>
+          <a:bodyPr wrap="square">
+            <a:spAutoFit/>
+          </a:bodyPr>
+          <a:lstStyle/>
+          <a:p>
+            <a:pPr algn="ctr">
+              <a:defRPr sz="2200" b="1">
+                <a:solidFill>
+                  <a:srgbClr val="38BDF8"/>
+                </a:solidFill>
+                <a:latin typeface="Calibri"/>
+              </a:defRPr>
+            </a:pPr>
+            <a:r>
+              <a:t>25+</a:t>
+            </a:r>
+          </a:p>
+        </p:txBody>
+      </p:sp>
+      <p:sp>
+        <p:nvSpPr>
+          <p:cNvPr id="36" name="TextBox 35"/>
+          <p:cNvSpPr txBox="1"/>
+          <p:nvPr/>
+        </p:nvSpPr>
+        <p:spPr>
+          <a:xfrm>
+            <a:off x="5120640" y="6446520"/>
+            <a:ext cx="2011680" cy="320040"/>
+          </a:xfrm>
+          <a:prstGeom prst="rect">
+            <a:avLst/>
+          </a:prstGeom>
+          <a:noFill/>
+        </p:spPr>
+        <p:txBody>
+          <a:bodyPr wrap="square">
+            <a:spAutoFit/>
+          </a:bodyPr>
+          <a:lstStyle/>
+          <a:p>
+            <a:pPr algn="ctr">
+              <a:defRPr sz="2200" b="1">
+                <a:solidFill>
+                  <a:srgbClr val="FBBF24"/>
+                </a:solidFill>
+                <a:latin typeface="Calibri"/>
+              </a:defRPr>
+            </a:pPr>
+            <a:r>
+              <a:t>30+</a:t>
+            </a:r>
+          </a:p>
+        </p:txBody>
+      </p:sp>
+      <p:sp>
+        <p:nvSpPr>
+          <p:cNvPr id="37" name="TextBox 36"/>
+          <p:cNvSpPr txBox="1"/>
+          <p:nvPr/>
+        </p:nvSpPr>
+        <p:spPr>
+          <a:xfrm>
+            <a:off x="7406640" y="6446520"/>
+            <a:ext cx="2011680" cy="320040"/>
+          </a:xfrm>
+          <a:prstGeom prst="rect">
+            <a:avLst/>
+          </a:prstGeom>
+          <a:noFill/>
+        </p:spPr>
+        <p:txBody>
+          <a:bodyPr wrap="square">
+            <a:spAutoFit/>
+          </a:bodyPr>
+          <a:lstStyle/>
+          <a:p>
+            <a:pPr algn="ctr">
+              <a:defRPr sz="2200" b="1">
+                <a:solidFill>
+                  <a:srgbClr val="4ADE80"/>
+                </a:solidFill>
+                <a:latin typeface="Calibri"/>
+              </a:defRPr>
+            </a:pPr>
+            <a:r>
+              <a:t>99.99%</a:t>
+            </a:r>
+          </a:p>
+        </p:txBody>
+      </p:sp>
+      <p:sp>
+        <p:nvSpPr>
+          <p:cNvPr id="38" name="TextBox 37"/>
+          <p:cNvSpPr txBox="1"/>
+          <p:nvPr/>
+        </p:nvSpPr>
+        <p:spPr>
+          <a:xfrm>
+            <a:off x="9692640" y="6446520"/>
+            <a:ext cx="2011680" cy="320040"/>
+          </a:xfrm>
+          <a:prstGeom prst="rect">
+            <a:avLst/>
+          </a:prstGeom>
+          <a:noFill/>
+        </p:spPr>
+        <p:txBody>
+          <a:bodyPr wrap="square">
+            <a:spAutoFit/>
+          </a:bodyPr>
+          <a:lstStyle/>
+          <a:p>
+            <a:pPr algn="ctr">
+              <a:defRPr sz="2200" b="1">
+                <a:solidFill>
+                  <a:srgbClr val="A855F7"/>
+                </a:solidFill>
+                <a:latin typeface="Calibri"/>
+              </a:defRPr>
+            </a:pPr>
+            <a:r>
+              <a:t>$1M+</a:t>
             </a:r>
           </a:p>
         </p:txBody>

</xml_diff>